<commit_message>
powerpoint slightly modified - no impact
</commit_message>
<xml_diff>
--- a/CDSD_Concepteur_Developpeur_Sciences_Donnees/Presentations_certification/ppt_versions/Bloc2_CDSD_Loic_Valentini.pptx
+++ b/CDSD_Concepteur_Developpeur_Sciences_Donnees/Presentations_certification/ppt_versions/Bloc2_CDSD_Loic_Valentini.pptx
@@ -13840,7 +13840,7 @@
         </p:nvSpPr>
         <p:spPr>
           <a:xfrm>
-            <a:off x="985351" y="861107"/>
+            <a:off x="985351" y="1347605"/>
             <a:ext cx="7944236" cy="533100"/>
           </a:xfrm>
           <a:prstGeom prst="rect">
@@ -13929,56 +13929,6 @@
               </a:rPr>
             </a:br>
             <a:br>
-              <a:rPr lang="fr-FR" sz="1000" dirty="0">
-                <a:latin typeface="Inter Medium" panose="020B0604020202020204" charset="0"/>
-                <a:ea typeface="Inter Medium" panose="020B0604020202020204" charset="0"/>
-              </a:rPr>
-            </a:br>
-            <a:r>
-              <a:rPr lang="fr-FR" sz="1400" dirty="0">
-                <a:latin typeface="Inter Medium" panose="020B0604020202020204" charset="0"/>
-                <a:ea typeface="Inter Medium" panose="020B0604020202020204" charset="0"/>
-              </a:rPr>
-              <a:t>Segmenter par métier ou centres d’intérêt.</a:t>
-            </a:r>
-            <a:br>
-              <a:rPr lang="fr-FR" sz="1400" dirty="0">
-                <a:latin typeface="Inter Medium" panose="020B0604020202020204" charset="0"/>
-                <a:ea typeface="Inter Medium" panose="020B0604020202020204" charset="0"/>
-              </a:rPr>
-            </a:br>
-            <a:br>
-              <a:rPr lang="fr-FR" sz="1000" dirty="0">
-                <a:latin typeface="Inter Medium" panose="020B0604020202020204" charset="0"/>
-                <a:ea typeface="Inter Medium" panose="020B0604020202020204" charset="0"/>
-              </a:rPr>
-            </a:br>
-            <a:br>
-              <a:rPr lang="fr-FR" sz="1400" dirty="0">
-                <a:latin typeface="Inter Medium" panose="020B0604020202020204" charset="0"/>
-                <a:ea typeface="Inter Medium" panose="020B0604020202020204" charset="0"/>
-              </a:rPr>
-            </a:br>
-            <a:r>
-              <a:rPr lang="fr-FR" sz="1400" dirty="0">
-                <a:latin typeface="Inter Medium" panose="020B0604020202020204" charset="0"/>
-                <a:ea typeface="Inter Medium" panose="020B0604020202020204" charset="0"/>
-              </a:rPr>
-              <a:t>Réduire la fatigue grâce à un design de rotation équilibré.</a:t>
-            </a:r>
-            <a:br>
-              <a:rPr lang="fr-FR" sz="1400" dirty="0">
-                <a:latin typeface="Inter Medium" panose="020B0604020202020204" charset="0"/>
-                <a:ea typeface="Inter Medium" panose="020B0604020202020204" charset="0"/>
-              </a:rPr>
-            </a:br>
-            <a:br>
-              <a:rPr lang="fr-FR" sz="1000" dirty="0">
-                <a:latin typeface="Inter Medium" panose="020B0604020202020204" charset="0"/>
-                <a:ea typeface="Inter Medium" panose="020B0604020202020204" charset="0"/>
-              </a:rPr>
-            </a:br>
-            <a:br>
               <a:rPr lang="fr-FR" sz="1400" dirty="0">
                 <a:latin typeface="Inter Medium" panose="020B0604020202020204" charset="0"/>
                 <a:ea typeface="Inter Medium" panose="020B0604020202020204" charset="0"/>
@@ -14092,7 +14042,7 @@
         </p:nvSpPr>
         <p:spPr>
           <a:xfrm rot="21244006">
-            <a:off x="646892" y="1271130"/>
+            <a:off x="588459" y="1754119"/>
             <a:ext cx="261199" cy="46747"/>
           </a:xfrm>
           <a:prstGeom prst="roundRect">
@@ -14140,7 +14090,7 @@
         </p:nvSpPr>
         <p:spPr>
           <a:xfrm rot="21244006">
-            <a:off x="651088" y="1824336"/>
+            <a:off x="592655" y="2307325"/>
             <a:ext cx="261199" cy="46747"/>
           </a:xfrm>
           <a:prstGeom prst="roundRect">
@@ -14188,55 +14138,7 @@
         </p:nvSpPr>
         <p:spPr>
           <a:xfrm rot="21244006">
-            <a:off x="646892" y="2399853"/>
-            <a:ext cx="261199" cy="46747"/>
-          </a:xfrm>
-          <a:prstGeom prst="roundRect">
-            <a:avLst>
-              <a:gd name="adj" fmla="val 50000"/>
-            </a:avLst>
-          </a:prstGeom>
-          <a:solidFill>
-            <a:srgbClr val="C3FFFC"/>
-          </a:solidFill>
-          <a:ln>
-            <a:noFill/>
-          </a:ln>
-        </p:spPr>
-        <p:txBody>
-          <a:bodyPr spcFirstLastPara="1" wrap="square" lIns="91425" tIns="91425" rIns="91425" bIns="91425" anchor="ctr" anchorCtr="0">
-            <a:noAutofit/>
-          </a:bodyPr>
-          <a:lstStyle/>
-          <a:p>
-            <a:pPr marL="0" lvl="0" indent="0" algn="l" rtl="0">
-              <a:spcBef>
-                <a:spcPts val="0"/>
-              </a:spcBef>
-              <a:spcAft>
-                <a:spcPts val="0"/>
-              </a:spcAft>
-              <a:buNone/>
-            </a:pPr>
-            <a:endParaRPr/>
-          </a:p>
-        </p:txBody>
-      </p:sp>
-      <p:sp>
-        <p:nvSpPr>
-          <p:cNvPr id="11" name="Google Shape;72;p15">
-            <a:extLst>
-              <a:ext uri="{FF2B5EF4-FFF2-40B4-BE49-F238E27FC236}">
-                <a16:creationId xmlns:a16="http://schemas.microsoft.com/office/drawing/2014/main" id="{4A90B45F-BA0F-4387-91B1-C2764DAA586A}"/>
-              </a:ext>
-            </a:extLst>
-          </p:cNvPr>
-          <p:cNvSpPr/>
-          <p:nvPr/>
-        </p:nvSpPr>
-        <p:spPr>
-          <a:xfrm rot="21244006">
-            <a:off x="646891" y="2919409"/>
+            <a:off x="588459" y="2882842"/>
             <a:ext cx="261199" cy="46747"/>
           </a:xfrm>
           <a:prstGeom prst="roundRect">
@@ -14310,54 +14212,6 @@
               <a:t>9</a:t>
             </a:fld>
             <a:endParaRPr lang="fr-FR" sz="1600" b="1" dirty="0"/>
-          </a:p>
-        </p:txBody>
-      </p:sp>
-      <p:sp>
-        <p:nvSpPr>
-          <p:cNvPr id="3" name="Google Shape;72;p15">
-            <a:extLst>
-              <a:ext uri="{FF2B5EF4-FFF2-40B4-BE49-F238E27FC236}">
-                <a16:creationId xmlns:a16="http://schemas.microsoft.com/office/drawing/2014/main" id="{8964D3B4-17A9-B594-18E8-B2727928ABF0}"/>
-              </a:ext>
-            </a:extLst>
-          </p:cNvPr>
-          <p:cNvSpPr/>
-          <p:nvPr/>
-        </p:nvSpPr>
-        <p:spPr>
-          <a:xfrm rot="21244006">
-            <a:off x="646891" y="3504893"/>
-            <a:ext cx="261199" cy="46747"/>
-          </a:xfrm>
-          <a:prstGeom prst="roundRect">
-            <a:avLst>
-              <a:gd name="adj" fmla="val 50000"/>
-            </a:avLst>
-          </a:prstGeom>
-          <a:solidFill>
-            <a:srgbClr val="C3FFFC"/>
-          </a:solidFill>
-          <a:ln>
-            <a:noFill/>
-          </a:ln>
-        </p:spPr>
-        <p:txBody>
-          <a:bodyPr spcFirstLastPara="1" wrap="square" lIns="91425" tIns="91425" rIns="91425" bIns="91425" anchor="ctr" anchorCtr="0">
-            <a:noAutofit/>
-          </a:bodyPr>
-          <a:lstStyle/>
-          <a:p>
-            <a:pPr marL="0" lvl="0" indent="0" algn="l" rtl="0">
-              <a:spcBef>
-                <a:spcPts val="0"/>
-              </a:spcBef>
-              <a:spcAft>
-                <a:spcPts val="0"/>
-              </a:spcAft>
-              <a:buNone/>
-            </a:pPr>
-            <a:endParaRPr/>
           </a:p>
         </p:txBody>
       </p:sp>
@@ -14422,7 +14276,7 @@
         </p:nvSpPr>
         <p:spPr>
           <a:xfrm rot="21244006">
-            <a:off x="646891" y="4094614"/>
+            <a:off x="588459" y="3482531"/>
             <a:ext cx="261199" cy="46747"/>
           </a:xfrm>
           <a:prstGeom prst="roundRect">

</xml_diff>